<commit_message>
fixed the open new tab and word file size
</commit_message>
<xml_diff>
--- a/docs/content/multivariate_statistics/multivariate_statistics_lecture.pptx
+++ b/docs/content/multivariate_statistics/multivariate_statistics_lecture.pptx
@@ -21505,7 +21505,7 @@
                 </a:solidFill>
                 <a:latin typeface="Courier"/>
               </a:rPr>
-              <a:t>##          Df SumOfSqs      R2      F Pr(&gt;F)   </a:t>
+              <a:t>##          Df SumOfSqs      R2      F Pr(&gt;F)    </a:t>
             </a:r>
             <a:br/>
             <a:r>
@@ -21515,7 +21515,7 @@
                 </a:solidFill>
                 <a:latin typeface="Courier"/>
               </a:rPr>
-              <a:t>## Model     1    47.72 0.10517 5.6414  0.003 **</a:t>
+              <a:t>## Model     1    47.72 0.10517 5.6414  0.001 ***</a:t>
             </a:r>
             <a:br/>
             <a:r>
@@ -21525,7 +21525,7 @@
                 </a:solidFill>
                 <a:latin typeface="Courier"/>
               </a:rPr>
-              <a:t>## Residual 48   406.06 0.89483                 </a:t>
+              <a:t>## Residual 48   406.06 0.89483                  </a:t>
             </a:r>
             <a:br/>
             <a:r>
@@ -21535,7 +21535,7 @@
                 </a:solidFill>
                 <a:latin typeface="Courier"/>
               </a:rPr>
-              <a:t>## Total    49   453.78 1.00000                 </a:t>
+              <a:t>## Total    49   453.78 1.00000                  </a:t>
             </a:r>
             <a:br/>
             <a:r>
@@ -21675,7 +21675,7 @@
                 </a:solidFill>
                 <a:latin typeface="Courier"/>
               </a:rPr>
-              <a:t>## Model     1    26.24 0.06493 3.3333  0.021 *</a:t>
+              <a:t>## Model     1    26.24 0.06493 3.3333  0.025 *</a:t>
             </a:r>
             <a:br/>
             <a:r>
@@ -22346,7 +22346,7 @@
                 </a:solidFill>
                 <a:latin typeface="Courier"/>
               </a:rPr>
-              <a:t>## LEH 0.120 0.006 -    </a:t>
+              <a:t>## LEH 0.132 0.006 -    </a:t>
             </a:r>
             <a:br/>
             <a:r>
@@ -22356,7 +22356,7 @@
                 </a:solidFill>
                 <a:latin typeface="Courier"/>
               </a:rPr>
-              <a:t>## TJH 0.012 0.006 0.012</a:t>
+              <a:t>## TJH 0.018 0.006 0.048</a:t>
             </a:r>
             <a:br/>
             <a:r>

</xml_diff>